<commit_message>
feat(net3): freeze reproducible three-zone baseline + post-review experiments
Post-review calibration rework (supervisor review 25 Jul 2026):

- wq_common.py: frozen baseline config + WNTR/EPANET helpers (monitors,
  zone assignment, seeds, priors, sigma=0.1 as one standard deviation)
- step1_freeze_baseline.py: cache all 2000 candidate predictions
  (C_all 2000x49x92); reproduces draft 4.4 exactly (1685/2000 behavioural,
  min RMSE 0.098, kw_old -0.96+/-0.32, avg -0.12+/-0.045, new -0.053+/-0.027)
- step3_threshold_sensitivity.py: RMSE thresholds 0.107/0.11/0.12 from cache
- step4_displaced_prior.py: displaced-prior identifiability test
- RESULTS_LOG.md + baseline_cache/*.json result summaries

Also bundles supervisor review PDF, meeting recordings/notes, thesis
figures (for_word + candidates) and draft snapshots; updates .gitignore.

Co-authored-by: Cursor <cursoragent@cursor.com>
</commit_message>
<xml_diff>
--- a/meetings/我/7.3.pptx
+++ b/meetings/我/7.3.pptx
@@ -5,7 +5,7 @@
     <p:sldMasterId id="2147483648" r:id="rId1"/>
   </p:sldMasterIdLst>
   <p:notesMasterIdLst>
-    <p:notesMasterId r:id="rId9"/>
+    <p:notesMasterId r:id="rId6"/>
   </p:notesMasterIdLst>
   <p:handoutMasterIdLst>
     <p:handoutMasterId r:id="rId19"/>
@@ -14,9 +14,9 @@
     <p:sldId id="256" r:id="rId3"/>
     <p:sldId id="259" r:id="rId4"/>
     <p:sldId id="265" r:id="rId5"/>
-    <p:sldId id="261" r:id="rId6"/>
-    <p:sldId id="262" r:id="rId7"/>
-    <p:sldId id="266" r:id="rId8"/>
+    <p:sldId id="261" r:id="rId7"/>
+    <p:sldId id="262" r:id="rId8"/>
+    <p:sldId id="266" r:id="rId9"/>
     <p:sldId id="267" r:id="rId10"/>
     <p:sldId id="279" r:id="rId11"/>
     <p:sldId id="268" r:id="rId12"/>
@@ -652,6 +652,622 @@
 </file>
 
 <file path=ppt/notesSlides/notesSlide1.xml><?xml version="1.0" encoding="utf-8"?>
+<p:notes xmlns:a="http://schemas.openxmlformats.org/drawingml/2006/main" xmlns:r="http://schemas.openxmlformats.org/officeDocument/2006/relationships" xmlns:p="http://schemas.openxmlformats.org/presentationml/2006/main">
+  <p:cSld>
+    <p:spTree>
+      <p:nvGrpSpPr>
+        <p:cNvPr id="1" name=""/>
+        <p:cNvGrpSpPr/>
+        <p:nvPr/>
+      </p:nvGrpSpPr>
+      <p:grpSpPr/>
+      <p:sp>
+        <p:nvSpPr>
+          <p:cNvPr id="2" name="幻灯片图像占位符 1"/>
+          <p:cNvSpPr>
+            <a:spLocks noGrp="1"/>
+          </p:cNvSpPr>
+          <p:nvPr>
+            <p:ph type="sldImg" idx="2"/>
+          </p:nvPr>
+        </p:nvSpPr>
+        <p:spPr/>
+      </p:sp>
+      <p:sp>
+        <p:nvSpPr>
+          <p:cNvPr id="3" name="文本占位符 2"/>
+          <p:cNvSpPr>
+            <a:spLocks noGrp="1"/>
+          </p:cNvSpPr>
+          <p:nvPr>
+            <p:ph type="body" idx="3"/>
+          </p:nvPr>
+        </p:nvSpPr>
+        <p:spPr/>
+        <p:txBody>
+          <a:bodyPr/>
+          <a:p>
+            <a:r>
+              <a:rPr lang="en-US" altLang="zh-CN"/>
+              <a:t>1. GA </a:t>
+            </a:r>
+            <a:r>
+              <a:rPr lang="zh-CN" altLang="en-US"/>
+              <a:t>是干什么的？</a:t>
+            </a:r>
+            <a:endParaRPr lang="zh-CN" altLang="en-US"/>
+          </a:p>
+          <a:p>
+            <a:endParaRPr lang="en-US" altLang="zh-CN"/>
+          </a:p>
+          <a:p>
+            <a:r>
+              <a:rPr lang="en-US" altLang="zh-CN"/>
+              <a:t>GA = Genetic Algorithm，</a:t>
+            </a:r>
+            <a:r>
+              <a:rPr lang="zh-CN" altLang="en-US"/>
+              <a:t>遗传算法。</a:t>
+            </a:r>
+            <a:endParaRPr lang="zh-CN" altLang="en-US"/>
+          </a:p>
+          <a:p>
+            <a:endParaRPr lang="en-US" altLang="zh-CN"/>
+          </a:p>
+          <a:p>
+            <a:r>
+              <a:rPr lang="zh-CN" altLang="en-US"/>
+              <a:t>它主要回答的问题是：</a:t>
+            </a:r>
+            <a:endParaRPr lang="zh-CN" altLang="en-US"/>
+          </a:p>
+          <a:p>
+            <a:endParaRPr lang="en-US" altLang="zh-CN"/>
+          </a:p>
+          <a:p>
+            <a:r>
+              <a:rPr lang="zh-CN" altLang="en-US"/>
+              <a:t>哪一组参数让模拟值和观测值最接近？</a:t>
+            </a:r>
+            <a:endParaRPr lang="zh-CN" altLang="en-US"/>
+          </a:p>
+          <a:p>
+            <a:endParaRPr lang="en-US" altLang="zh-CN"/>
+          </a:p>
+          <a:p>
+            <a:r>
+              <a:rPr lang="zh-CN" altLang="en-US"/>
+              <a:t>也就是找一个 </a:t>
+            </a:r>
+            <a:r>
+              <a:rPr lang="en-US" altLang="zh-CN"/>
+              <a:t>best-fit：</a:t>
+            </a:r>
+            <a:endParaRPr lang="en-US" altLang="zh-CN"/>
+          </a:p>
+          <a:p>
+            <a:endParaRPr lang="en-US" altLang="zh-CN"/>
+          </a:p>
+          <a:p>
+            <a:r>
+              <a:rPr lang="en-US" altLang="zh-CN"/>
+              <a:t>(kw,old ,kw,average ,kw,new)</a:t>
+            </a:r>
+            <a:endParaRPr lang="en-US" altLang="zh-CN"/>
+          </a:p>
+          <a:p>
+            <a:endParaRPr lang="en-US" altLang="zh-CN"/>
+          </a:p>
+          <a:p>
+            <a:r>
+              <a:rPr lang="en-US" altLang="zh-CN"/>
+              <a:t>GA </a:t>
+            </a:r>
+            <a:r>
+              <a:rPr lang="zh-CN" altLang="en-US"/>
+              <a:t>的优点是适合找最优解，尤其参数空间比较复杂时，它比普通 </a:t>
+            </a:r>
+            <a:r>
+              <a:rPr lang="en-US" altLang="zh-CN"/>
+              <a:t>grid search </a:t>
+            </a:r>
+            <a:r>
+              <a:rPr lang="zh-CN" altLang="en-US"/>
+              <a:t>更灵活。</a:t>
+            </a:r>
+            <a:endParaRPr lang="zh-CN" altLang="en-US"/>
+          </a:p>
+          <a:p>
+            <a:endParaRPr lang="en-US" altLang="zh-CN"/>
+          </a:p>
+          <a:p>
+            <a:r>
+              <a:rPr lang="zh-CN" altLang="en-US"/>
+              <a:t>但是它的问题是：</a:t>
+            </a:r>
+            <a:endParaRPr lang="zh-CN" altLang="en-US"/>
+          </a:p>
+          <a:p>
+            <a:endParaRPr lang="en-US" altLang="zh-CN"/>
+          </a:p>
+          <a:p>
+            <a:r>
+              <a:rPr lang="zh-CN" altLang="en-US"/>
+              <a:t>它通常最后给你一个“最优参数组合”，但不直接告诉你还有多少别的参数组合也差不多好。</a:t>
+            </a:r>
+            <a:endParaRPr lang="zh-CN" altLang="en-US"/>
+          </a:p>
+          <a:p>
+            <a:endParaRPr lang="en-US" altLang="zh-CN"/>
+          </a:p>
+          <a:p>
+            <a:r>
+              <a:rPr lang="zh-CN" altLang="en-US"/>
+              <a:t>在你的论文里，这不够。因为你的结果已经说明，很多不同的 </a:t>
+            </a:r>
+            <a:r>
+              <a:rPr lang="en-US" altLang="zh-CN"/>
+              <a:t>kw</a:t>
+            </a:r>
+            <a:r>
+              <a:rPr lang="zh-CN" altLang="en-US"/>
+              <a:t>组合都能解释 </a:t>
+            </a:r>
+            <a:r>
+              <a:rPr lang="en-US" altLang="zh-CN"/>
+              <a:t>noisy observations。</a:t>
+            </a:r>
+            <a:r>
+              <a:rPr lang="zh-CN" altLang="en-US"/>
+              <a:t>所以如果只用 </a:t>
+            </a:r>
+            <a:r>
+              <a:rPr lang="en-US" altLang="zh-CN"/>
+              <a:t>GA，</a:t>
+            </a:r>
+            <a:r>
+              <a:rPr lang="zh-CN" altLang="en-US"/>
+              <a:t>你可能会得到一个看起来很准的 </a:t>
+            </a:r>
+            <a:r>
+              <a:rPr lang="en-US" altLang="zh-CN"/>
+              <a:t>best-fit，</a:t>
+            </a:r>
+            <a:r>
+              <a:rPr lang="zh-CN" altLang="en-US"/>
+              <a:t>但会隐藏参数不可辨识的问题。</a:t>
+            </a:r>
+            <a:endParaRPr lang="zh-CN" altLang="en-US"/>
+          </a:p>
+          <a:p>
+            <a:endParaRPr lang="en-US" altLang="zh-CN"/>
+          </a:p>
+          <a:p>
+            <a:r>
+              <a:rPr lang="zh-CN" altLang="en-US"/>
+              <a:t>简单说：</a:t>
+            </a:r>
+            <a:endParaRPr lang="zh-CN" altLang="en-US"/>
+          </a:p>
+          <a:p>
+            <a:endParaRPr lang="en-US" altLang="zh-CN"/>
+          </a:p>
+          <a:p>
+            <a:r>
+              <a:rPr lang="en-US" altLang="zh-CN"/>
+              <a:t>GA </a:t>
+            </a:r>
+            <a:r>
+              <a:rPr lang="zh-CN" altLang="en-US"/>
+              <a:t>适合找最优值，但不适合直接表达“这个最优值有多不确定”。</a:t>
+            </a:r>
+            <a:endParaRPr lang="zh-CN" altLang="en-US"/>
+          </a:p>
+          <a:p>
+            <a:endParaRPr lang="en-US" altLang="zh-CN"/>
+          </a:p>
+          <a:p>
+            <a:r>
+              <a:rPr lang="en-US" altLang="zh-CN"/>
+              <a:t>2. Bayesian / MCMC </a:t>
+            </a:r>
+            <a:r>
+              <a:rPr lang="zh-CN" altLang="en-US"/>
+              <a:t>是干什么的？</a:t>
+            </a:r>
+            <a:endParaRPr lang="zh-CN" altLang="en-US"/>
+          </a:p>
+          <a:p>
+            <a:endParaRPr lang="en-US" altLang="zh-CN"/>
+          </a:p>
+          <a:p>
+            <a:r>
+              <a:rPr lang="en-US" altLang="zh-CN"/>
+              <a:t>Bayesian / MCMC </a:t>
+            </a:r>
+            <a:r>
+              <a:rPr lang="zh-CN" altLang="en-US"/>
+              <a:t>主要回答的问题是：</a:t>
+            </a:r>
+            <a:endParaRPr lang="zh-CN" altLang="en-US"/>
+          </a:p>
+          <a:p>
+            <a:endParaRPr lang="en-US" altLang="zh-CN"/>
+          </a:p>
+          <a:p>
+            <a:r>
+              <a:rPr lang="zh-CN" altLang="en-US"/>
+              <a:t>在给定观测数据和统计假设后，参数的 </a:t>
+            </a:r>
+            <a:r>
+              <a:rPr lang="en-US" altLang="zh-CN"/>
+              <a:t>posterior distribution </a:t>
+            </a:r>
+            <a:r>
+              <a:rPr lang="zh-CN" altLang="en-US"/>
+              <a:t>是什么？</a:t>
+            </a:r>
+            <a:endParaRPr lang="zh-CN" altLang="en-US"/>
+          </a:p>
+          <a:p>
+            <a:endParaRPr lang="en-US" altLang="zh-CN"/>
+          </a:p>
+          <a:p>
+            <a:r>
+              <a:rPr lang="zh-CN" altLang="en-US"/>
+              <a:t>它比 </a:t>
+            </a:r>
+            <a:r>
+              <a:rPr lang="en-US" altLang="zh-CN"/>
+              <a:t>GLUE </a:t>
+            </a:r>
+            <a:r>
+              <a:rPr lang="zh-CN" altLang="en-US"/>
+              <a:t>更正式，因为它可以给出严格意义上的 </a:t>
+            </a:r>
+            <a:r>
+              <a:rPr lang="en-US" altLang="zh-CN"/>
+              <a:t>posterior distribution。</a:t>
+            </a:r>
+            <a:endParaRPr lang="en-US" altLang="zh-CN"/>
+          </a:p>
+          <a:p>
+            <a:endParaRPr lang="en-US" altLang="zh-CN"/>
+          </a:p>
+          <a:p>
+            <a:r>
+              <a:rPr lang="zh-CN" altLang="en-US"/>
+              <a:t>但是它有几个问题：</a:t>
+            </a:r>
+            <a:endParaRPr lang="zh-CN" altLang="en-US"/>
+          </a:p>
+          <a:p>
+            <a:endParaRPr lang="en-US" altLang="zh-CN"/>
+          </a:p>
+          <a:p>
+            <a:r>
+              <a:rPr lang="zh-CN" altLang="en-US"/>
+              <a:t>你需要定义很明确的 </a:t>
+            </a:r>
+            <a:r>
+              <a:rPr lang="en-US" altLang="zh-CN"/>
+              <a:t>likelihood；</a:t>
+            </a:r>
+            <a:endParaRPr lang="en-US" altLang="zh-CN"/>
+          </a:p>
+          <a:p>
+            <a:r>
+              <a:rPr lang="zh-CN" altLang="en-US"/>
+              <a:t>你需要合理设置 </a:t>
+            </a:r>
+            <a:r>
+              <a:rPr lang="en-US" altLang="zh-CN"/>
+              <a:t>prior；</a:t>
+            </a:r>
+            <a:endParaRPr lang="en-US" altLang="zh-CN"/>
+          </a:p>
+          <a:p>
+            <a:r>
+              <a:rPr lang="zh-CN" altLang="en-US"/>
+              <a:t>你要清楚 </a:t>
+            </a:r>
+            <a:r>
+              <a:rPr lang="en-US" altLang="zh-CN"/>
+              <a:t>measurement error、model error、hydraulic error </a:t>
+            </a:r>
+            <a:r>
+              <a:rPr lang="zh-CN" altLang="en-US"/>
+              <a:t>怎么进入模型；</a:t>
+            </a:r>
+            <a:endParaRPr lang="zh-CN" altLang="en-US"/>
+          </a:p>
+          <a:p>
+            <a:r>
+              <a:rPr lang="en-US" altLang="zh-CN"/>
+              <a:t>MCMC </a:t>
+            </a:r>
+            <a:r>
+              <a:rPr lang="zh-CN" altLang="en-US"/>
+              <a:t>计算量可能很大，因为每一步都要跑 </a:t>
+            </a:r>
+            <a:r>
+              <a:rPr lang="en-US" altLang="zh-CN"/>
+              <a:t>WNTR/EPANET；</a:t>
+            </a:r>
+            <a:endParaRPr lang="en-US" altLang="zh-CN"/>
+          </a:p>
+          <a:p>
+            <a:r>
+              <a:rPr lang="zh-CN" altLang="en-US"/>
+              <a:t>如果模型误差和传感器误差没有定义清楚，</a:t>
+            </a:r>
+            <a:r>
+              <a:rPr lang="en-US" altLang="zh-CN"/>
+              <a:t>Bayesian </a:t>
+            </a:r>
+            <a:r>
+              <a:rPr lang="zh-CN" altLang="en-US"/>
+              <a:t>的“严格性”反而可能是假严格。</a:t>
+            </a:r>
+            <a:endParaRPr lang="zh-CN" altLang="en-US"/>
+          </a:p>
+          <a:p>
+            <a:endParaRPr lang="en-US" altLang="zh-CN"/>
+          </a:p>
+          <a:p>
+            <a:r>
+              <a:rPr lang="zh-CN" altLang="en-US"/>
+              <a:t>你的论文现在是 </a:t>
+            </a:r>
+            <a:r>
+              <a:rPr lang="en-US" altLang="zh-CN"/>
+              <a:t>Net3 synthetic prototype，</a:t>
+            </a:r>
+            <a:r>
+              <a:rPr lang="zh-CN" altLang="en-US"/>
+              <a:t>不是真实网络完整 </a:t>
+            </a:r>
+            <a:r>
+              <a:rPr lang="en-US" altLang="zh-CN"/>
+              <a:t>Bayesian inference。</a:t>
+            </a:r>
+            <a:r>
+              <a:rPr lang="zh-CN" altLang="en-US"/>
+              <a:t>因此直接上 </a:t>
+            </a:r>
+            <a:r>
+              <a:rPr lang="en-US" altLang="zh-CN"/>
+              <a:t>Bayesian/MCMC </a:t>
+            </a:r>
+            <a:r>
+              <a:rPr lang="zh-CN" altLang="en-US"/>
+              <a:t>会显得过重，而且需要解释很多额外统计假设。</a:t>
+            </a:r>
+            <a:endParaRPr lang="zh-CN" altLang="en-US"/>
+          </a:p>
+          <a:p>
+            <a:endParaRPr lang="en-US" altLang="zh-CN"/>
+          </a:p>
+          <a:p>
+            <a:r>
+              <a:rPr lang="zh-CN" altLang="en-US"/>
+              <a:t>简单说：</a:t>
+            </a:r>
+            <a:r>
+              <a:rPr lang="en-US" altLang="zh-CN"/>
+              <a:t>Bayesian/MCMC </a:t>
+            </a:r>
+            <a:r>
+              <a:rPr lang="zh-CN" altLang="en-US"/>
+              <a:t>更正式，但要求更高、计算更重、假设更多。</a:t>
+            </a:r>
+            <a:endParaRPr lang="zh-CN" altLang="en-US"/>
+          </a:p>
+          <a:p>
+            <a:endParaRPr lang="en-US" altLang="zh-CN"/>
+          </a:p>
+          <a:p>
+            <a:r>
+              <a:rPr lang="en-US" altLang="zh-CN"/>
+              <a:t>3. GLUE </a:t>
+            </a:r>
+            <a:r>
+              <a:rPr lang="zh-CN" altLang="en-US"/>
+              <a:t>是干什么的？</a:t>
+            </a:r>
+            <a:endParaRPr lang="zh-CN" altLang="en-US"/>
+          </a:p>
+          <a:p>
+            <a:endParaRPr lang="en-US" altLang="zh-CN"/>
+          </a:p>
+          <a:p>
+            <a:r>
+              <a:rPr lang="en-US" altLang="zh-CN"/>
+              <a:t>GLUE </a:t>
+            </a:r>
+            <a:r>
+              <a:rPr lang="zh-CN" altLang="en-US"/>
+              <a:t>回答的问题是：</a:t>
+            </a:r>
+            <a:endParaRPr lang="zh-CN" altLang="en-US"/>
+          </a:p>
+          <a:p>
+            <a:endParaRPr lang="en-US" altLang="zh-CN"/>
+          </a:p>
+          <a:p>
+            <a:r>
+              <a:rPr lang="zh-CN" altLang="en-US"/>
+              <a:t>哪些参数组合都能在可接受误差范围内解释观测数据？</a:t>
+            </a:r>
+            <a:endParaRPr lang="zh-CN" altLang="en-US"/>
+          </a:p>
+          <a:p>
+            <a:endParaRPr lang="en-US" altLang="zh-CN"/>
+          </a:p>
+          <a:p>
+            <a:r>
+              <a:rPr lang="zh-CN" altLang="en-US"/>
+              <a:t>它不是只找一个最优解，而是保留很多组 </a:t>
+            </a:r>
+            <a:r>
+              <a:rPr lang="en-US" altLang="zh-CN"/>
+              <a:t>behavioural parameter sets。</a:t>
+            </a:r>
+            <a:endParaRPr lang="en-US" altLang="zh-CN"/>
+          </a:p>
+          <a:p>
+            <a:endParaRPr lang="en-US" altLang="zh-CN"/>
+          </a:p>
+          <a:p>
+            <a:r>
+              <a:rPr lang="zh-CN" altLang="en-US"/>
+              <a:t>比如你采样 2000 组三个 </a:t>
+            </a:r>
+            <a:r>
+              <a:rPr lang="en-US" altLang="zh-CN"/>
+              <a:t>kw：</a:t>
+            </a:r>
+            <a:endParaRPr lang="en-US" altLang="zh-CN"/>
+          </a:p>
+          <a:p>
+            <a:endParaRPr lang="en-US" altLang="zh-CN"/>
+          </a:p>
+          <a:p>
+            <a:r>
+              <a:rPr lang="en-US" altLang="zh-CN"/>
+              <a:t>(kw,old ,kw,average ,kw,new)</a:t>
+            </a:r>
+            <a:endParaRPr lang="en-US" altLang="zh-CN"/>
+          </a:p>
+          <a:p>
+            <a:endParaRPr lang="en-US" altLang="zh-CN"/>
+          </a:p>
+          <a:p>
+            <a:r>
+              <a:rPr lang="zh-CN" altLang="en-US"/>
+              <a:t>然后看哪些组合的 </a:t>
+            </a:r>
+            <a:r>
+              <a:rPr lang="en-US" altLang="zh-CN"/>
+              <a:t>RMSE </a:t>
+            </a:r>
+            <a:r>
+              <a:rPr lang="zh-CN" altLang="en-US"/>
+              <a:t>小于阈值。满足条件的保留下来，并给它们权重。</a:t>
+            </a:r>
+            <a:endParaRPr lang="zh-CN" altLang="en-US"/>
+          </a:p>
+          <a:p>
+            <a:endParaRPr lang="en-US" altLang="zh-CN"/>
+          </a:p>
+          <a:p>
+            <a:r>
+              <a:rPr lang="zh-CN" altLang="en-US"/>
+              <a:t>所以 </a:t>
+            </a:r>
+            <a:r>
+              <a:rPr lang="en-US" altLang="zh-CN"/>
+              <a:t>GLUE </a:t>
+            </a:r>
+            <a:r>
+              <a:rPr lang="zh-CN" altLang="en-US"/>
+              <a:t>的输出不是：</a:t>
+            </a:r>
+            <a:endParaRPr lang="en-US" altLang="zh-CN"/>
+          </a:p>
+          <a:p>
+            <a:r>
+              <a:rPr lang="zh-CN" altLang="en-US"/>
+              <a:t>这一个 </a:t>
+            </a:r>
+            <a:r>
+              <a:rPr lang="en-US" altLang="zh-CN"/>
+              <a:t>kw</a:t>
+            </a:r>
+            <a:r>
+              <a:rPr lang="zh-CN" altLang="en-US"/>
+              <a:t>是答案。</a:t>
+            </a:r>
+            <a:endParaRPr lang="zh-CN" altLang="en-US"/>
+          </a:p>
+          <a:p>
+            <a:endParaRPr lang="en-US" altLang="zh-CN"/>
+          </a:p>
+          <a:p>
+            <a:r>
+              <a:rPr lang="zh-CN" altLang="en-US"/>
+              <a:t>而是：这些 </a:t>
+            </a:r>
+            <a:r>
+              <a:rPr lang="en-US" altLang="zh-CN"/>
+              <a:t>kw</a:t>
+            </a:r>
+            <a:r>
+              <a:rPr lang="zh-CN" altLang="en-US"/>
+              <a:t> 组合都可能合理，只是权重不同。</a:t>
+            </a:r>
+            <a:endParaRPr lang="zh-CN" altLang="en-US"/>
+          </a:p>
+          <a:p>
+            <a:endParaRPr lang="en-US" altLang="zh-CN"/>
+          </a:p>
+          <a:p>
+            <a:r>
+              <a:rPr lang="zh-CN" altLang="en-US"/>
+              <a:t>这正好适合你的论文，因为你的核心发现是：</a:t>
+            </a:r>
+            <a:endParaRPr lang="zh-CN" altLang="en-US"/>
+          </a:p>
+          <a:p>
+            <a:r>
+              <a:rPr lang="en-US" altLang="zh-CN"/>
+              <a:t>Grid search </a:t>
+            </a:r>
+            <a:r>
+              <a:rPr lang="zh-CN" altLang="en-US"/>
+              <a:t>可以找到接近真值的 </a:t>
+            </a:r>
+            <a:r>
+              <a:rPr lang="en-US" altLang="zh-CN"/>
+              <a:t>best-fit，</a:t>
+            </a:r>
+            <a:r>
+              <a:rPr lang="zh-CN" altLang="en-US"/>
+              <a:t>但 </a:t>
+            </a:r>
+            <a:r>
+              <a:rPr lang="en-US" altLang="zh-CN"/>
+              <a:t>GLUE </a:t>
+            </a:r>
+            <a:r>
+              <a:rPr lang="zh-CN" altLang="en-US"/>
+              <a:t>显示参数范围没有明显收窄，说明 </a:t>
+            </a:r>
+            <a:r>
+              <a:rPr lang="en-US" altLang="zh-CN"/>
+              <a:t>kw</a:t>
+            </a:r>
+            <a:r>
+              <a:rPr lang="zh-CN" altLang="en-US"/>
+              <a:t>是 </a:t>
+            </a:r>
+            <a:r>
+              <a:rPr lang="en-US" altLang="zh-CN"/>
+              <a:t>weakly identifiable。</a:t>
+            </a:r>
+            <a:endParaRPr lang="en-US" altLang="zh-CN"/>
+          </a:p>
+        </p:txBody>
+      </p:sp>
+    </p:spTree>
+  </p:cSld>
+  <p:clrMapOvr>
+    <a:masterClrMapping/>
+  </p:clrMapOvr>
+</p:notes>
+</file>
+
+<file path=ppt/notesSlides/notesSlide2.xml><?xml version="1.0" encoding="utf-8"?>
 <p:notes xmlns:a="http://schemas.openxmlformats.org/drawingml/2006/main" xmlns:r="http://schemas.openxmlformats.org/officeDocument/2006/relationships" xmlns:p="http://schemas.openxmlformats.org/presentationml/2006/main">
   <p:cSld>
     <p:spTree>

</xml_diff>